<commit_message>
feat: input C (graf A-J, B->H) - graf_C.txt, test, tangkapan layar, analisis README, slide & naskah
</commit_message>
<xml_diff>
--- a/Docs/Slide Presentasi Tugas 1 – Shortest Path Dijkstra vs A.pptx
+++ b/Docs/Slide Presentasi Tugas 1 – Shortest Path Dijkstra vs A.pptx
@@ -19,6 +19,7 @@
     <p:sldId id="267" r:id="rId13"/>
     <p:sldId id="268" r:id="rId14"/>
     <p:sldId id="269" r:id="rId15"/>
+    <p:sldId id="273" r:id="rId24"/>
     <p:sldId id="270" r:id="rId16"/>
     <p:sldId id="271" r:id="rId17"/>
     <p:sldId id="272" r:id="rId18"/>
@@ -7067,7 +7068,7 @@
                 <a:ea typeface="IBM Plex Sans" pitchFamily="34" charset="-122"/>
                 <a:cs typeface="IBM Plex Sans" pitchFamily="34" charset="-120"/>
               </a:rPr>
-              <a:t>15</a:t>
+              <a:t>16</a:t>
             </a:r>
             <a:endParaRPr lang="en-US" sz="1200" dirty="0"/>
           </a:p>
@@ -7829,7 +7830,7 @@
                 <a:ea typeface="IBM Plex Sans" pitchFamily="34" charset="-122"/>
                 <a:cs typeface="IBM Plex Sans" pitchFamily="34" charset="-120"/>
               </a:rPr>
-              <a:t>16</a:t>
+              <a:t>17</a:t>
             </a:r>
             <a:endParaRPr lang="en-US" sz="1200" dirty="0"/>
           </a:p>
@@ -8194,7 +8195,599 @@
                 <a:ea typeface="IBM Plex Sans" pitchFamily="34" charset="-122"/>
                 <a:cs typeface="IBM Plex Sans" pitchFamily="34" charset="-120"/>
               </a:rPr>
-              <a:t>17</a:t>
+              <a:t>18</a:t>
+            </a:r>
+            <a:endParaRPr lang="en-US" sz="1200" dirty="0"/>
+          </a:p>
+        </p:txBody>
+      </p:sp>
+    </p:spTree>
+  </p:cSld>
+  <p:clrMapOvr>
+    <a:masterClrMapping/>
+  </p:clrMapOvr>
+</p:sld>
+</file>
+
+<file path=ppt/slides/slide18.xml><?xml version="1.0" encoding="utf-8"?>
+<p:sld xmlns:a="http://schemas.openxmlformats.org/drawingml/2006/main" xmlns:r="http://schemas.openxmlformats.org/officeDocument/2006/relationships" xmlns:p="http://schemas.openxmlformats.org/presentationml/2006/main">
+  <p:cSld name="Slide 13">
+    <p:bg>
+      <p:bgPr>
+        <a:solidFill>
+          <a:srgbClr val="F5F3EE"/>
+        </a:solidFill>
+      </p:bgPr>
+    </p:bg>
+    <p:spTree>
+      <p:nvGrpSpPr>
+        <p:cNvPr id="1" name=""/>
+        <p:cNvGrpSpPr/>
+        <p:nvPr/>
+      </p:nvGrpSpPr>
+      <p:grpSpPr>
+        <a:xfrm>
+          <a:off x="0" y="0"/>
+          <a:ext cx="0" cy="0"/>
+          <a:chOff x="0" y="0"/>
+          <a:chExt cx="0" cy="0"/>
+        </a:xfrm>
+      </p:grpSpPr>
+      <p:sp>
+        <p:nvSpPr>
+          <p:cNvPr id="2" name="Text 0"/>
+          <p:cNvSpPr/>
+          <p:nvPr/>
+        </p:nvSpPr>
+        <p:spPr>
+          <a:xfrm>
+            <a:off x="812780" y="812775"/>
+            <a:ext cx="10883434" cy="238760"/>
+          </a:xfrm>
+          <a:prstGeom prst="rect">
+            <a:avLst/>
+          </a:prstGeom>
+          <a:noFill/>
+          <a:ln/>
+        </p:spPr>
+        <p:txBody>
+          <a:bodyPr wrap="square" lIns="0" tIns="0" rIns="0" bIns="0" rtlCol="0" anchor="t">
+            <a:normAutofit/>
+          </a:bodyPr>
+          <a:lstStyle/>
+          <a:p>
+            <a:pPr algn="l" indent="0" marL="0">
+              <a:lnSpc>
+                <a:spcPts val="1680"/>
+              </a:lnSpc>
+              <a:buNone/>
+            </a:pPr>
+            <a:r>
+              <a:rPr lang="en-US" sz="1200" b="1" spc="150" kern="0" dirty="0">
+                <a:solidFill>
+                  <a:srgbClr val="6D35D6"/>
+                </a:solidFill>
+                <a:latin typeface="IBM Plex Sans" pitchFamily="34" charset="0"/>
+                <a:ea typeface="IBM Plex Sans" pitchFamily="34" charset="-122"/>
+                <a:cs typeface="IBM Plex Sans" pitchFamily="34" charset="-120"/>
+              </a:rPr>
+              <a:t>ANALISIS · INPUT C</a:t>
+            </a:r>
+            <a:endParaRPr lang="en-US" sz="1200" dirty="0"/>
+          </a:p>
+        </p:txBody>
+      </p:sp>
+      <p:sp>
+        <p:nvSpPr>
+          <p:cNvPr id="3" name="Text 1"/>
+          <p:cNvSpPr/>
+          <p:nvPr>
+            <p:ph type="title"/>
+          </p:nvPr>
+        </p:nvSpPr>
+        <p:spPr>
+          <a:xfrm>
+            <a:off x="812780" y="1102339"/>
+            <a:ext cx="10883434" cy="472420"/>
+          </a:xfrm>
+          <a:prstGeom prst="rect">
+            <a:avLst/>
+          </a:prstGeom>
+          <a:noFill/>
+          <a:ln/>
+        </p:spPr>
+        <p:txBody>
+          <a:bodyPr wrap="square" lIns="0" tIns="0" rIns="0" bIns="0" rtlCol="0" anchor="t">
+            <a:normAutofit/>
+          </a:bodyPr>
+          <a:lstStyle/>
+          <a:p>
+            <a:pPr algn="l" indent="0" marL="0">
+              <a:lnSpc>
+                <a:spcPts val="3520"/>
+              </a:lnSpc>
+              <a:buNone/>
+            </a:pPr>
+            <a:r>
+              <a:rPr lang="en-US" sz="3200" b="1" i="0" dirty="0">
+                <a:solidFill>
+                  <a:srgbClr val="14233B"/>
+                </a:solidFill>
+                <a:latin typeface="Space Grotesk" pitchFamily="34" charset="0"/>
+                <a:ea typeface="Space Grotesk" pitchFamily="34" charset="-122"/>
+                <a:cs typeface="Space Grotesk" pitchFamily="34" charset="-120"/>
+              </a:rPr>
+              <a:t>Bobot sama (9), A* hanya hemat satu simpul</a:t>
+            </a:r>
+            <a:endParaRPr lang="en-US" sz="3200" dirty="0"/>
+          </a:p>
+        </p:txBody>
+      </p:sp>
+      <p:sp>
+        <p:nvSpPr>
+          <p:cNvPr id="4" name="Text 2"/>
+          <p:cNvSpPr/>
+          <p:nvPr/>
+        </p:nvSpPr>
+        <p:spPr>
+          <a:xfrm>
+            <a:off x="812780" y="1854157"/>
+            <a:ext cx="5232441" cy="330200"/>
+          </a:xfrm>
+          <a:prstGeom prst="rect">
+            <a:avLst/>
+          </a:prstGeom>
+          <a:noFill/>
+          <a:ln/>
+        </p:spPr>
+        <p:txBody>
+          <a:bodyPr wrap="square" lIns="0" tIns="0" rIns="0" bIns="0" rtlCol="0" anchor="t">
+            <a:normAutofit/>
+          </a:bodyPr>
+          <a:lstStyle/>
+          <a:p>
+            <a:pPr algn="l" indent="0" marL="0">
+              <a:lnSpc>
+                <a:spcPts val="2400"/>
+              </a:lnSpc>
+              <a:buNone/>
+            </a:pPr>
+            <a:r>
+              <a:rPr lang="en-US" sz="2000" b="1" dirty="0">
+                <a:solidFill>
+                  <a:srgbClr val="14233B"/>
+                </a:solidFill>
+                <a:latin typeface="Space Grotesk" pitchFamily="34" charset="0"/>
+                <a:ea typeface="Space Grotesk" pitchFamily="34" charset="-122"/>
+                <a:cs typeface="Space Grotesk" pitchFamily="34" charset="-120"/>
+              </a:rPr>
+              <a:t>Dijkstra</a:t>
+            </a:r>
+            <a:endParaRPr lang="en-US" sz="2000" dirty="0"/>
+          </a:p>
+        </p:txBody>
+      </p:sp>
+      <p:sp>
+        <p:nvSpPr>
+          <p:cNvPr id="5" name="Text 3"/>
+          <p:cNvSpPr/>
+          <p:nvPr/>
+        </p:nvSpPr>
+        <p:spPr>
+          <a:xfrm>
+            <a:off x="812780" y="2235157"/>
+            <a:ext cx="5232441" cy="523200"/>
+          </a:xfrm>
+          <a:prstGeom prst="rect">
+            <a:avLst/>
+          </a:prstGeom>
+          <a:noFill/>
+          <a:ln/>
+        </p:spPr>
+        <p:txBody>
+          <a:bodyPr wrap="square" lIns="0" tIns="0" rIns="0" bIns="0" rtlCol="0" anchor="t">
+            <a:normAutofit/>
+          </a:bodyPr>
+          <a:lstStyle/>
+          <a:p>
+            <a:pPr algn="l" indent="0" marL="0">
+              <a:lnSpc>
+                <a:spcPts val="1960"/>
+              </a:lnSpc>
+              <a:buNone/>
+            </a:pPr>
+            <a:r>
+              <a:rPr lang="en-US" sz="1400" b="1" dirty="0">
+                <a:solidFill>
+                  <a:srgbClr val="3E4A5C"/>
+                </a:solidFill>
+                <a:latin typeface="IBM Plex Sans" pitchFamily="34" charset="0"/>
+                <a:ea typeface="IBM Plex Sans" pitchFamily="34" charset="-122"/>
+                <a:cs typeface="IBM Plex Sans" pitchFamily="34" charset="-120"/>
+              </a:rPr>
+              <a:t>8 dari 10</a:t>
+            </a:r>
+            <a:r>
+              <a:rPr lang="en-US" sz="1400" dirty="0">
+                <a:solidFill>
+                  <a:srgbClr val="3E4A5C"/>
+                </a:solidFill>
+                <a:latin typeface="IBM Plex Sans" pitchFamily="34" charset="0"/>
+                <a:ea typeface="IBM Plex Sans" pitchFamily="34" charset="-122"/>
+                <a:cs typeface="IBM Plex Sans" pitchFamily="34" charset="-120"/>
+              </a:rPr>
+              <a:t> simpul diperluas · 12 relaksasi</a:t>
+            </a:r>
+            <a:endParaRPr lang="en-US" sz="1400" dirty="0"/>
+          </a:p>
+          <a:p>
+            <a:pPr algn="l" indent="0" marL="0">
+              <a:lnSpc>
+                <a:spcPts val="1960"/>
+              </a:lnSpc>
+              <a:buNone/>
+            </a:pPr>
+            <a:r>
+              <a:rPr lang="en-US" sz="1400" dirty="0">
+                <a:solidFill>
+                  <a:srgbClr val="3E4A5C"/>
+                </a:solidFill>
+                <a:latin typeface="IBM Plex Sans" pitchFamily="34" charset="0"/>
+                <a:ea typeface="IBM Plex Sans" pitchFamily="34" charset="-122"/>
+                <a:cs typeface="IBM Plex Sans" pitchFamily="34" charset="-120"/>
+              </a:rPr>
+              <a:t>Waktu contoh 9,79 µs · G ikut diambil karena seri d = 9</a:t>
+            </a:r>
+            <a:endParaRPr lang="en-US" sz="1400" dirty="0"/>
+          </a:p>
+        </p:txBody>
+      </p:sp>
+      <p:sp>
+        <p:nvSpPr>
+          <p:cNvPr id="6" name="Shape 4"/>
+          <p:cNvSpPr/>
+          <p:nvPr/>
+        </p:nvSpPr>
+        <p:spPr>
+          <a:xfrm>
+            <a:off x="812780" y="2809156"/>
+            <a:ext cx="4825960" cy="2755880"/>
+          </a:xfrm>
+          <a:prstGeom prst="roundRect">
+            <a:avLst>
+              <a:gd name="adj" fmla="val 2765"/>
+            </a:avLst>
+          </a:prstGeom>
+          <a:solidFill>
+            <a:srgbClr val="F7F9FC"/>
+          </a:solidFill>
+          <a:ln/>
+        </p:spPr>
+      </p:sp>
+      <p:pic>
+        <p:nvPicPr>
+          <p:cNvPr id="7" name="Image 0" descr="Dijkstra: 12 simpul biru muda (diperluas), termasuk V3, V6, V7, V8, V10">    </p:cNvPr>
+          <p:cNvPicPr>
+            <a:picLocks noChangeAspect="1"/>
+          </p:cNvPicPr>
+          <p:nvPr/>
+        </p:nvPicPr>
+        <p:blipFill>
+          <a:blip r:embed="rId1"/>
+          <a:srcRect l="-82" r="-82" t="0" b="0"/>
+          <a:stretch/>
+        </p:blipFill>
+        <p:spPr>
+          <a:xfrm>
+            <a:off x="819130" y="2815506"/>
+            <a:ext cx="4813260" cy="2743180"/>
+          </a:xfrm>
+          <a:prstGeom prst="roundRect">
+            <a:avLst>
+              <a:gd name="adj" fmla="val 2546"/>
+            </a:avLst>
+          </a:prstGeom>
+        </p:spPr>
+      </p:pic>
+      <p:sp>
+        <p:nvSpPr>
+          <p:cNvPr id="8" name="Shape 5"/>
+          <p:cNvSpPr/>
+          <p:nvPr/>
+        </p:nvSpPr>
+        <p:spPr>
+          <a:xfrm>
+            <a:off x="815955" y="2812331"/>
+            <a:ext cx="4819610" cy="2749530"/>
+          </a:xfrm>
+          <a:prstGeom prst="roundRect">
+            <a:avLst>
+              <a:gd name="adj" fmla="val 2656"/>
+            </a:avLst>
+          </a:prstGeom>
+          <a:noFill/>
+          <a:ln w="6350">
+            <a:solidFill>
+              <a:srgbClr val="DDD8CC"/>
+            </a:solidFill>
+            <a:prstDash val="solid"/>
+          </a:ln>
+        </p:spPr>
+      </p:sp>
+      <p:sp>
+        <p:nvSpPr>
+          <p:cNvPr id="9" name="Text 6"/>
+          <p:cNvSpPr/>
+          <p:nvPr/>
+        </p:nvSpPr>
+        <p:spPr>
+          <a:xfrm>
+            <a:off x="6299180" y="1854157"/>
+            <a:ext cx="5232441" cy="330200"/>
+          </a:xfrm>
+          <a:prstGeom prst="rect">
+            <a:avLst/>
+          </a:prstGeom>
+          <a:noFill/>
+          <a:ln/>
+        </p:spPr>
+        <p:txBody>
+          <a:bodyPr wrap="square" lIns="0" tIns="0" rIns="0" bIns="0" rtlCol="0" anchor="t">
+            <a:normAutofit/>
+          </a:bodyPr>
+          <a:lstStyle/>
+          <a:p>
+            <a:pPr algn="l" indent="0" marL="0">
+              <a:lnSpc>
+                <a:spcPts val="2400"/>
+              </a:lnSpc>
+              <a:buNone/>
+            </a:pPr>
+            <a:r>
+              <a:rPr lang="en-US" sz="2000" b="1" dirty="0">
+                <a:solidFill>
+                  <a:srgbClr val="6D35D6"/>
+                </a:solidFill>
+                <a:latin typeface="Space Grotesk" pitchFamily="34" charset="0"/>
+                <a:ea typeface="Space Grotesk" pitchFamily="34" charset="-122"/>
+                <a:cs typeface="Space Grotesk" pitchFamily="34" charset="-120"/>
+              </a:rPr>
+              <a:t>A*</a:t>
+            </a:r>
+            <a:endParaRPr lang="en-US" sz="2000" dirty="0"/>
+          </a:p>
+        </p:txBody>
+      </p:sp>
+      <p:sp>
+        <p:nvSpPr>
+          <p:cNvPr id="10" name="Text 7"/>
+          <p:cNvSpPr/>
+          <p:nvPr/>
+        </p:nvSpPr>
+        <p:spPr>
+          <a:xfrm>
+            <a:off x="6299180" y="2235157"/>
+            <a:ext cx="5232441" cy="523200"/>
+          </a:xfrm>
+          <a:prstGeom prst="rect">
+            <a:avLst/>
+          </a:prstGeom>
+          <a:noFill/>
+          <a:ln/>
+        </p:spPr>
+        <p:txBody>
+          <a:bodyPr wrap="square" lIns="0" tIns="0" rIns="0" bIns="0" rtlCol="0" anchor="t">
+            <a:normAutofit/>
+          </a:bodyPr>
+          <a:lstStyle/>
+          <a:p>
+            <a:pPr algn="l" indent="0" marL="0">
+              <a:lnSpc>
+                <a:spcPts val="1960"/>
+              </a:lnSpc>
+              <a:buNone/>
+            </a:pPr>
+            <a:r>
+              <a:rPr lang="en-US" sz="1400" b="1" dirty="0">
+                <a:solidFill>
+                  <a:srgbClr val="3E4A5C"/>
+                </a:solidFill>
+                <a:latin typeface="IBM Plex Sans" pitchFamily="34" charset="0"/>
+                <a:ea typeface="IBM Plex Sans" pitchFamily="34" charset="-122"/>
+                <a:cs typeface="IBM Plex Sans" pitchFamily="34" charset="-120"/>
+              </a:rPr>
+              <a:t>7 dari 10</a:t>
+            </a:r>
+            <a:r>
+              <a:rPr lang="en-US" sz="1400" dirty="0">
+                <a:solidFill>
+                  <a:srgbClr val="3E4A5C"/>
+                </a:solidFill>
+                <a:latin typeface="IBM Plex Sans" pitchFamily="34" charset="0"/>
+                <a:ea typeface="IBM Plex Sans" pitchFamily="34" charset="-122"/>
+                <a:cs typeface="IBM Plex Sans" pitchFamily="34" charset="-120"/>
+              </a:rPr>
+              <a:t> simpul diperluas · 11 relaksasi</a:t>
+            </a:r>
+            <a:endParaRPr lang="en-US" sz="1400" dirty="0"/>
+          </a:p>
+          <a:p>
+            <a:pPr algn="l" indent="0" marL="0">
+              <a:lnSpc>
+                <a:spcPts val="1960"/>
+              </a:lnSpc>
+              <a:buNone/>
+            </a:pPr>
+            <a:r>
+              <a:rPr lang="en-US" sz="1400" dirty="0">
+                <a:solidFill>
+                  <a:srgbClr val="3E4A5C"/>
+                </a:solidFill>
+                <a:latin typeface="IBM Plex Sans" pitchFamily="34" charset="0"/>
+                <a:ea typeface="IBM Plex Sans" pitchFamily="34" charset="-122"/>
+                <a:cs typeface="IBM Plex Sans" pitchFamily="34" charset="-120"/>
+              </a:rPr>
+              <a:t>Waktu contoh 25,00 µs (±2,6× lebih lambat)</a:t>
+            </a:r>
+            <a:endParaRPr lang="en-US" sz="1400" dirty="0"/>
+          </a:p>
+        </p:txBody>
+      </p:sp>
+      <p:sp>
+        <p:nvSpPr>
+          <p:cNvPr id="11" name="Shape 8"/>
+          <p:cNvSpPr/>
+          <p:nvPr/>
+        </p:nvSpPr>
+        <p:spPr>
+          <a:xfrm>
+            <a:off x="6299180" y="2809156"/>
+            <a:ext cx="4825960" cy="2755880"/>
+          </a:xfrm>
+          <a:prstGeom prst="roundRect">
+            <a:avLst>
+              <a:gd name="adj" fmla="val 2765"/>
+            </a:avLst>
+          </a:prstGeom>
+          <a:solidFill>
+            <a:srgbClr val="F7F9FC"/>
+          </a:solidFill>
+          <a:ln/>
+        </p:spPr>
+      </p:sp>
+      <p:pic>
+        <p:nvPicPr>
+          <p:cNvPr id="12" name="Image 1" descr="A*: hanya 7 simpul biru muda di sepanjang jalur, simpul lain tidak disentuh">    </p:cNvPr>
+          <p:cNvPicPr>
+            <a:picLocks noChangeAspect="1"/>
+          </p:cNvPicPr>
+          <p:nvPr/>
+        </p:nvPicPr>
+        <p:blipFill>
+          <a:blip r:embed="rId2"/>
+          <a:srcRect l="-82" r="-82" t="0" b="0"/>
+          <a:stretch/>
+        </p:blipFill>
+        <p:spPr>
+          <a:xfrm>
+            <a:off x="6305530" y="2815506"/>
+            <a:ext cx="4813260" cy="2743180"/>
+          </a:xfrm>
+          <a:prstGeom prst="roundRect">
+            <a:avLst>
+              <a:gd name="adj" fmla="val 2546"/>
+            </a:avLst>
+          </a:prstGeom>
+        </p:spPr>
+      </p:pic>
+      <p:sp>
+        <p:nvSpPr>
+          <p:cNvPr id="13" name="Shape 9"/>
+          <p:cNvSpPr/>
+          <p:nvPr/>
+        </p:nvSpPr>
+        <p:spPr>
+          <a:xfrm>
+            <a:off x="6302355" y="2812331"/>
+            <a:ext cx="4819610" cy="2749530"/>
+          </a:xfrm>
+          <a:prstGeom prst="roundRect">
+            <a:avLst>
+              <a:gd name="adj" fmla="val 2656"/>
+            </a:avLst>
+          </a:prstGeom>
+          <a:noFill/>
+          <a:ln w="6350">
+            <a:solidFill>
+              <a:srgbClr val="DDD8CC"/>
+            </a:solidFill>
+            <a:prstDash val="solid"/>
+          </a:ln>
+        </p:spPr>
+      </p:sp>
+      <p:sp>
+        <p:nvSpPr>
+          <p:cNvPr id="14" name="Text 10"/>
+          <p:cNvSpPr/>
+          <p:nvPr/>
+        </p:nvSpPr>
+        <p:spPr>
+          <a:xfrm>
+            <a:off x="812780" y="6235774"/>
+            <a:ext cx="4687800" cy="241260"/>
+          </a:xfrm>
+          <a:prstGeom prst="rect">
+            <a:avLst/>
+          </a:prstGeom>
+          <a:noFill/>
+          <a:ln/>
+        </p:spPr>
+        <p:txBody>
+          <a:bodyPr wrap="square" lIns="0" tIns="0" rIns="0" bIns="0" rtlCol="0" anchor="t">
+            <a:normAutofit/>
+          </a:bodyPr>
+          <a:lstStyle/>
+          <a:p>
+            <a:pPr algn="l" indent="0" marL="0">
+              <a:lnSpc>
+                <a:spcPts val="1680"/>
+              </a:lnSpc>
+              <a:buNone/>
+            </a:pPr>
+            <a:r>
+              <a:rPr lang="en-US" sz="1200" dirty="0">
+                <a:solidFill>
+                  <a:srgbClr val="5F6B7A"/>
+                </a:solidFill>
+                <a:latin typeface="IBM Plex Sans" pitchFamily="34" charset="0"/>
+                <a:ea typeface="IBM Plex Sans" pitchFamily="34" charset="-122"/>
+                <a:cs typeface="IBM Plex Sans" pitchFamily="34" charset="-120"/>
+              </a:rPr>
+              <a:t>Pembicara 4 · [Nama 4] · w_min = 1, jadi h hanya jumlah hop dan kurang informatif</a:t>
+            </a:r>
+            <a:endParaRPr lang="en-US" sz="1200" dirty="0"/>
+          </a:p>
+        </p:txBody>
+      </p:sp>
+      <p:sp>
+        <p:nvSpPr>
+          <p:cNvPr id="15" name="Text 11"/>
+          <p:cNvSpPr/>
+          <p:nvPr/>
+        </p:nvSpPr>
+        <p:spPr>
+          <a:xfrm>
+            <a:off x="11145541" y="6235774"/>
+            <a:ext cx="233680" cy="241260"/>
+          </a:xfrm>
+          <a:prstGeom prst="rect">
+            <a:avLst/>
+          </a:prstGeom>
+          <a:noFill/>
+          <a:ln/>
+        </p:spPr>
+        <p:txBody>
+          <a:bodyPr wrap="square" lIns="0" tIns="0" rIns="0" bIns="0" rtlCol="0" anchor="t">
+            <a:normAutofit/>
+          </a:bodyPr>
+          <a:lstStyle/>
+          <a:p>
+            <a:pPr algn="r" indent="0" marL="0">
+              <a:lnSpc>
+                <a:spcPts val="1680"/>
+              </a:lnSpc>
+              <a:buNone/>
+            </a:pPr>
+            <a:r>
+              <a:rPr lang="en-US" sz="1200" dirty="0">
+                <a:solidFill>
+                  <a:srgbClr val="5F6B7A"/>
+                </a:solidFill>
+                <a:latin typeface="IBM Plex Sans" pitchFamily="34" charset="0"/>
+                <a:ea typeface="IBM Plex Sans" pitchFamily="34" charset="-122"/>
+                <a:cs typeface="IBM Plex Sans" pitchFamily="34" charset="-120"/>
+              </a:rPr>
+              <a:t>15</a:t>
             </a:r>
             <a:endParaRPr lang="en-US" sz="1200" dirty="0"/>
           </a:p>

</xml_diff>